<commit_message>
bug found in threshold failure of >2 continguous runs meeting threshold
</commit_message>
<xml_diff>
--- a/Presentations/May Motif Gallery.pptx
+++ b/Presentations/May Motif Gallery.pptx
@@ -5,7 +5,7 @@
     <p:sldMasterId id="2147483648" r:id="rId1"/>
   </p:sldMasterIdLst>
   <p:notesMasterIdLst>
-    <p:notesMasterId r:id="rId22"/>
+    <p:notesMasterId r:id="rId25"/>
   </p:notesMasterIdLst>
   <p:sldIdLst>
     <p:sldId id="256" r:id="rId2"/>
@@ -28,6 +28,9 @@
     <p:sldId id="273" r:id="rId19"/>
     <p:sldId id="274" r:id="rId20"/>
     <p:sldId id="275" r:id="rId21"/>
+    <p:sldId id="279" r:id="rId22"/>
+    <p:sldId id="276" r:id="rId23"/>
+    <p:sldId id="277" r:id="rId24"/>
   </p:sldIdLst>
   <p:sldSz cx="12192000" cy="6858000"/>
   <p:notesSz cx="6858000" cy="9144000"/>
@@ -4047,7 +4050,7 @@
           </p:nvPr>
         </p:nvPicPr>
         <p:blipFill>
-          <a:blip r:embed="rId2"/>
+          <a:blip/>
           <a:stretch>
             <a:fillRect/>
           </a:stretch>
@@ -4074,7 +4077,7 @@
           <p:nvPr/>
         </p:nvPicPr>
         <p:blipFill>
-          <a:blip r:embed="rId3"/>
+          <a:blip/>
           <a:stretch>
             <a:fillRect/>
           </a:stretch>
@@ -5572,7 +5575,7 @@
           <p:nvPr/>
         </p:nvPicPr>
         <p:blipFill>
-          <a:blip r:embed="rId2"/>
+          <a:blip/>
           <a:stretch>
             <a:fillRect/>
           </a:stretch>
@@ -5602,7 +5605,7 @@
           <p:nvPr/>
         </p:nvPicPr>
         <p:blipFill>
-          <a:blip r:embed="rId3"/>
+          <a:blip/>
           <a:stretch>
             <a:fillRect/>
           </a:stretch>
@@ -5632,7 +5635,7 @@
           <p:nvPr/>
         </p:nvPicPr>
         <p:blipFill>
-          <a:blip r:embed="rId4"/>
+          <a:blip/>
           <a:stretch>
             <a:fillRect/>
           </a:stretch>
@@ -5739,7 +5742,7 @@
           <p:nvPr/>
         </p:nvPicPr>
         <p:blipFill>
-          <a:blip r:embed="rId2"/>
+          <a:blip/>
           <a:stretch>
             <a:fillRect/>
           </a:stretch>
@@ -7292,7 +7295,7 @@
           <p:nvPr/>
         </p:nvPicPr>
         <p:blipFill>
-          <a:blip r:embed="rId3"/>
+          <a:blip/>
           <a:stretch>
             <a:fillRect/>
           </a:stretch>
@@ -7425,7 +7428,7 @@
           <p:nvPr/>
         </p:nvPicPr>
         <p:blipFill>
-          <a:blip r:embed="rId2"/>
+          <a:blip/>
           <a:stretch>
             <a:fillRect/>
           </a:stretch>
@@ -7455,7 +7458,7 @@
           <p:nvPr/>
         </p:nvPicPr>
         <p:blipFill>
-          <a:blip r:embed="rId3"/>
+          <a:blip/>
           <a:stretch>
             <a:fillRect/>
           </a:stretch>
@@ -7485,7 +7488,7 @@
           <p:nvPr/>
         </p:nvPicPr>
         <p:blipFill>
-          <a:blip r:embed="rId4"/>
+          <a:blip/>
           <a:stretch>
             <a:fillRect/>
           </a:stretch>
@@ -7595,7 +7598,7 @@
           <p:nvPr/>
         </p:nvPicPr>
         <p:blipFill>
-          <a:blip r:embed="rId2"/>
+          <a:blip/>
           <a:stretch>
             <a:fillRect/>
           </a:stretch>
@@ -9382,7 +9385,7 @@
           <p:nvPr/>
         </p:nvPicPr>
         <p:blipFill>
-          <a:blip r:embed="rId3"/>
+          <a:blip/>
           <a:stretch>
             <a:fillRect/>
           </a:stretch>
@@ -9444,7 +9447,7 @@
           </p:nvPr>
         </p:nvPicPr>
         <p:blipFill>
-          <a:blip r:embed="rId3">
+          <a:blip>
             <a:extLst>
               <a:ext uri="{28A0092B-C50C-407E-A947-70E740481C1C}">
                 <a14:useLocalDpi xmlns:a14="http://schemas.microsoft.com/office/drawing/2010/main" val="0"/>
@@ -9491,7 +9494,7 @@
         <p:spPr>
           <a:xfrm>
             <a:off x="5101272" y="1331367"/>
-            <a:ext cx="6404611" cy="5309146"/>
+            <a:ext cx="6800216" cy="4847481"/>
           </a:xfrm>
           <a:prstGeom prst="rect">
             <a:avLst/>
@@ -9665,7 +9668,7 @@
           <p:nvPr/>
         </p:nvPicPr>
         <p:blipFill>
-          <a:blip r:embed="rId4"/>
+          <a:blip/>
           <a:srcRect b="17782"/>
           <a:stretch>
             <a:fillRect/>
@@ -11017,7 +11020,7 @@
           <p:nvPr/>
         </p:nvPicPr>
         <p:blipFill>
-          <a:blip r:embed="rId2"/>
+          <a:blip/>
           <a:stretch>
             <a:fillRect/>
           </a:stretch>
@@ -11047,7 +11050,7 @@
           <p:nvPr/>
         </p:nvPicPr>
         <p:blipFill>
-          <a:blip r:embed="rId3"/>
+          <a:blip/>
           <a:srcRect b="17782"/>
           <a:stretch>
             <a:fillRect/>
@@ -11162,13 +11165,13 @@
           <a:p>
             <a:r>
               <a:rPr lang="en-US" dirty="0"/>
-              <a:t>Compute IC. If the IC is greater then discard the change, if not, discard the change </a:t>
+              <a:t>Compute IC. If the IC is lower then discard the change, if not, discard the change </a:t>
             </a:r>
           </a:p>
           <a:p>
             <a:r>
               <a:rPr lang="en-US" dirty="0"/>
-              <a:t>Goal is to make the IC go up high to a total of X bits </a:t>
+              <a:t>Goal is to construct high-IC situation </a:t>
             </a:r>
           </a:p>
           <a:p>
@@ -11183,6 +11186,1931 @@
     <p:extLst>
       <p:ext uri="{BB962C8B-B14F-4D97-AF65-F5344CB8AC3E}">
         <p14:creationId xmlns:p14="http://schemas.microsoft.com/office/powerpoint/2010/main" val="2932112272"/>
+      </p:ext>
+    </p:extLst>
+  </p:cSld>
+  <p:clrMapOvr>
+    <a:masterClrMapping/>
+  </p:clrMapOvr>
+</p:sld>
+</file>
+
+<file path=ppt/slides/slide21.xml><?xml version="1.0" encoding="utf-8"?>
+<p:sld xmlns:a="http://schemas.openxmlformats.org/drawingml/2006/main" xmlns:r="http://schemas.openxmlformats.org/officeDocument/2006/relationships" xmlns:p="http://schemas.openxmlformats.org/presentationml/2006/main">
+  <p:cSld>
+    <p:spTree>
+      <p:nvGrpSpPr>
+        <p:cNvPr id="1" name="">
+          <a:extLst>
+            <a:ext uri="{FF2B5EF4-FFF2-40B4-BE49-F238E27FC236}">
+              <a16:creationId xmlns:a16="http://schemas.microsoft.com/office/drawing/2014/main" id="{534D654E-AC08-0B7D-0ACA-9DD17346EB45}"/>
+            </a:ext>
+          </a:extLst>
+        </p:cNvPr>
+        <p:cNvGrpSpPr/>
+        <p:nvPr/>
+      </p:nvGrpSpPr>
+      <p:grpSpPr>
+        <a:xfrm>
+          <a:off x="0" y="0"/>
+          <a:ext cx="0" cy="0"/>
+          <a:chOff x="0" y="0"/>
+          <a:chExt cx="0" cy="0"/>
+        </a:xfrm>
+      </p:grpSpPr>
+      <p:sp>
+        <p:nvSpPr>
+          <p:cNvPr id="2" name="Title 1">
+            <a:extLst>
+              <a:ext uri="{FF2B5EF4-FFF2-40B4-BE49-F238E27FC236}">
+                <a16:creationId xmlns:a16="http://schemas.microsoft.com/office/drawing/2014/main" id="{B2FED843-2EA6-EBDA-5BA7-8A67A312321A}"/>
+              </a:ext>
+            </a:extLst>
+          </p:cNvPr>
+          <p:cNvSpPr>
+            <a:spLocks noGrp="1"/>
+          </p:cNvSpPr>
+          <p:nvPr>
+            <p:ph type="ctrTitle"/>
+          </p:nvPr>
+        </p:nvSpPr>
+        <p:spPr/>
+        <p:txBody>
+          <a:bodyPr/>
+          <a:lstStyle/>
+          <a:p>
+            <a:r>
+              <a:rPr lang="en-US" dirty="0" err="1"/>
+              <a:t>CollecTF</a:t>
+            </a:r>
+            <a:r>
+              <a:rPr lang="en-US" dirty="0"/>
+              <a:t> Gallery</a:t>
+            </a:r>
+          </a:p>
+        </p:txBody>
+      </p:sp>
+      <p:sp>
+        <p:nvSpPr>
+          <p:cNvPr id="3" name="Subtitle 2">
+            <a:extLst>
+              <a:ext uri="{FF2B5EF4-FFF2-40B4-BE49-F238E27FC236}">
+                <a16:creationId xmlns:a16="http://schemas.microsoft.com/office/drawing/2014/main" id="{FCE093F6-974A-AF7A-6982-521400A84638}"/>
+              </a:ext>
+            </a:extLst>
+          </p:cNvPr>
+          <p:cNvSpPr>
+            <a:spLocks noGrp="1"/>
+          </p:cNvSpPr>
+          <p:nvPr>
+            <p:ph type="subTitle" idx="1"/>
+          </p:nvPr>
+        </p:nvSpPr>
+        <p:spPr/>
+        <p:txBody>
+          <a:bodyPr/>
+          <a:lstStyle/>
+          <a:p>
+            <a:r>
+              <a:rPr lang="en-US"/>
+              <a:t>26 May </a:t>
+            </a:r>
+            <a:r>
+              <a:rPr lang="en-US" dirty="0"/>
+              <a:t>2026</a:t>
+            </a:r>
+          </a:p>
+        </p:txBody>
+      </p:sp>
+    </p:spTree>
+    <p:extLst>
+      <p:ext uri="{BB962C8B-B14F-4D97-AF65-F5344CB8AC3E}">
+        <p14:creationId xmlns:p14="http://schemas.microsoft.com/office/powerpoint/2010/main" val="931650567"/>
+      </p:ext>
+    </p:extLst>
+  </p:cSld>
+  <p:clrMapOvr>
+    <a:masterClrMapping/>
+  </p:clrMapOvr>
+</p:sld>
+</file>
+
+<file path=ppt/slides/slide22.xml><?xml version="1.0" encoding="utf-8"?>
+<p:sld xmlns:a="http://schemas.openxmlformats.org/drawingml/2006/main" xmlns:r="http://schemas.openxmlformats.org/officeDocument/2006/relationships" xmlns:p="http://schemas.openxmlformats.org/presentationml/2006/main">
+  <p:cSld>
+    <p:spTree>
+      <p:nvGrpSpPr>
+        <p:cNvPr id="1" name="">
+          <a:extLst>
+            <a:ext uri="{FF2B5EF4-FFF2-40B4-BE49-F238E27FC236}">
+              <a16:creationId xmlns:a16="http://schemas.microsoft.com/office/drawing/2014/main" id="{4CE59387-80CA-6854-350F-E03E8D1DDBB6}"/>
+            </a:ext>
+          </a:extLst>
+        </p:cNvPr>
+        <p:cNvGrpSpPr/>
+        <p:nvPr/>
+      </p:nvGrpSpPr>
+      <p:grpSpPr>
+        <a:xfrm>
+          <a:off x="0" y="0"/>
+          <a:ext cx="0" cy="0"/>
+          <a:chOff x="0" y="0"/>
+          <a:chExt cx="0" cy="0"/>
+        </a:xfrm>
+      </p:grpSpPr>
+      <p:pic>
+        <p:nvPicPr>
+          <p:cNvPr id="13" name="Picture 12">
+            <a:extLst>
+              <a:ext uri="{FF2B5EF4-FFF2-40B4-BE49-F238E27FC236}">
+                <a16:creationId xmlns:a16="http://schemas.microsoft.com/office/drawing/2014/main" id="{62180CC5-9247-7175-39A9-D2D148AF8725}"/>
+              </a:ext>
+            </a:extLst>
+          </p:cNvPr>
+          <p:cNvPicPr>
+            <a:picLocks noChangeAspect="1"/>
+          </p:cNvPicPr>
+          <p:nvPr/>
+        </p:nvPicPr>
+        <p:blipFill>
+          <a:blip r:embed="rId2"/>
+          <a:stretch>
+            <a:fillRect/>
+          </a:stretch>
+        </p:blipFill>
+        <p:spPr>
+          <a:xfrm>
+            <a:off x="0" y="2646918"/>
+            <a:ext cx="3994499" cy="3641450"/>
+          </a:xfrm>
+          <a:prstGeom prst="rect">
+            <a:avLst/>
+          </a:prstGeom>
+        </p:spPr>
+      </p:pic>
+      <p:sp>
+        <p:nvSpPr>
+          <p:cNvPr id="2" name="Title 1">
+            <a:extLst>
+              <a:ext uri="{FF2B5EF4-FFF2-40B4-BE49-F238E27FC236}">
+                <a16:creationId xmlns:a16="http://schemas.microsoft.com/office/drawing/2014/main" id="{A7239620-34A6-24BA-DE41-25BEB1358DA8}"/>
+              </a:ext>
+            </a:extLst>
+          </p:cNvPr>
+          <p:cNvSpPr>
+            <a:spLocks noGrp="1"/>
+          </p:cNvSpPr>
+          <p:nvPr>
+            <p:ph type="title"/>
+          </p:nvPr>
+        </p:nvSpPr>
+        <p:spPr>
+          <a:xfrm>
+            <a:off x="266701" y="27523"/>
+            <a:ext cx="10515600" cy="1325563"/>
+          </a:xfrm>
+        </p:spPr>
+        <p:txBody>
+          <a:bodyPr/>
+          <a:lstStyle/>
+          <a:p>
+            <a:r>
+              <a:rPr lang="en-US" dirty="0"/>
+              <a:t>One-sample case</a:t>
+            </a:r>
+          </a:p>
+        </p:txBody>
+      </p:sp>
+      <p:sp>
+        <p:nvSpPr>
+          <p:cNvPr id="5" name="TextBox 4">
+            <a:extLst>
+              <a:ext uri="{FF2B5EF4-FFF2-40B4-BE49-F238E27FC236}">
+                <a16:creationId xmlns:a16="http://schemas.microsoft.com/office/drawing/2014/main" id="{2EFEB458-427E-A1D5-A749-289988A28112}"/>
+              </a:ext>
+            </a:extLst>
+          </p:cNvPr>
+          <p:cNvSpPr txBox="1"/>
+          <p:nvPr/>
+        </p:nvSpPr>
+        <p:spPr>
+          <a:xfrm>
+            <a:off x="332186" y="1253113"/>
+            <a:ext cx="6100762" cy="954107"/>
+          </a:xfrm>
+          <a:prstGeom prst="rect">
+            <a:avLst/>
+          </a:prstGeom>
+          <a:noFill/>
+        </p:spPr>
+        <p:txBody>
+          <a:bodyPr wrap="square">
+            <a:spAutoFit/>
+          </a:bodyPr>
+          <a:lstStyle/>
+          <a:p>
+            <a:pPr algn="l" rtl="0">
+              <a:spcBef>
+                <a:spcPts val="1575"/>
+              </a:spcBef>
+              <a:spcAft>
+                <a:spcPts val="788"/>
+              </a:spcAft>
+              <a:buNone/>
+            </a:pPr>
+            <a:r>
+              <a:rPr lang="en-US" b="0" i="0" dirty="0" err="1">
+                <a:solidFill>
+                  <a:srgbClr val="2C3E50"/>
+                </a:solidFill>
+                <a:effectLst/>
+                <a:latin typeface="Lato" panose="020F0502020204030203" pitchFamily="34" charset="0"/>
+              </a:rPr>
+              <a:t>LexA</a:t>
+            </a:r>
+            <a:r>
+              <a:rPr lang="en-US" b="0" i="0" dirty="0">
+                <a:solidFill>
+                  <a:srgbClr val="2C3E50"/>
+                </a:solidFill>
+                <a:effectLst/>
+                <a:latin typeface="Lato" panose="020F0502020204030203" pitchFamily="34" charset="0"/>
+              </a:rPr>
+              <a:t> - </a:t>
+            </a:r>
+            <a:r>
+              <a:rPr lang="en-US" b="0" i="0" u="none" strike="noStrike" dirty="0">
+                <a:solidFill>
+                  <a:srgbClr val="18BC9C"/>
+                </a:solidFill>
+                <a:effectLst/>
+                <a:latin typeface="Lato" panose="020F0502020204030203" pitchFamily="34" charset="0"/>
+                <a:hlinkClick r:id="rId3"/>
+              </a:rPr>
+              <a:t>UniProtKB: Q8PN77 </a:t>
+            </a:r>
+            <a:endParaRPr lang="en-US" b="0" i="0" u="none" strike="noStrike" dirty="0">
+              <a:solidFill>
+                <a:srgbClr val="18BC9C"/>
+              </a:solidFill>
+              <a:effectLst/>
+              <a:latin typeface="Lato" panose="020F0502020204030203" pitchFamily="34" charset="0"/>
+            </a:endParaRPr>
+          </a:p>
+          <a:p>
+            <a:pPr algn="l" rtl="0">
+              <a:spcBef>
+                <a:spcPts val="1575"/>
+              </a:spcBef>
+              <a:spcAft>
+                <a:spcPts val="788"/>
+              </a:spcAft>
+              <a:buNone/>
+            </a:pPr>
+            <a:r>
+              <a:rPr lang="en-US" dirty="0">
+                <a:solidFill>
+                  <a:srgbClr val="18BC9C"/>
+                </a:solidFill>
+                <a:latin typeface="Lato" panose="020F0502020204030203" pitchFamily="34" charset="0"/>
+              </a:rPr>
+              <a:t>Both a reverse and direct</a:t>
+            </a:r>
+            <a:endParaRPr lang="en-US" b="0" i="0" dirty="0">
+              <a:solidFill>
+                <a:srgbClr val="2C3E50"/>
+              </a:solidFill>
+              <a:effectLst/>
+              <a:latin typeface="Lato" panose="020F0502020204030203" pitchFamily="34" charset="0"/>
+            </a:endParaRPr>
+          </a:p>
+        </p:txBody>
+      </p:sp>
+      <p:pic>
+        <p:nvPicPr>
+          <p:cNvPr id="6" name="Picture 5">
+            <a:extLst>
+              <a:ext uri="{FF2B5EF4-FFF2-40B4-BE49-F238E27FC236}">
+                <a16:creationId xmlns:a16="http://schemas.microsoft.com/office/drawing/2014/main" id="{F48E05D9-76D3-FFDC-5CF1-12C0CC62AC40}"/>
+              </a:ext>
+            </a:extLst>
+          </p:cNvPr>
+          <p:cNvPicPr>
+            <a:picLocks noChangeAspect="1"/>
+          </p:cNvPicPr>
+          <p:nvPr/>
+        </p:nvPicPr>
+        <p:blipFill>
+          <a:blip r:embed="rId4"/>
+          <a:stretch>
+            <a:fillRect/>
+          </a:stretch>
+        </p:blipFill>
+        <p:spPr>
+          <a:xfrm>
+            <a:off x="3527251" y="2646918"/>
+            <a:ext cx="3994499" cy="3641450"/>
+          </a:xfrm>
+          <a:prstGeom prst="rect">
+            <a:avLst/>
+          </a:prstGeom>
+        </p:spPr>
+      </p:pic>
+      <p:pic>
+        <p:nvPicPr>
+          <p:cNvPr id="7" name="Picture 6">
+            <a:extLst>
+              <a:ext uri="{FF2B5EF4-FFF2-40B4-BE49-F238E27FC236}">
+                <a16:creationId xmlns:a16="http://schemas.microsoft.com/office/drawing/2014/main" id="{05A69908-B5A2-3F64-4AF4-ABBF110DB5C1}"/>
+              </a:ext>
+            </a:extLst>
+          </p:cNvPr>
+          <p:cNvPicPr>
+            <a:picLocks noChangeAspect="1"/>
+          </p:cNvPicPr>
+          <p:nvPr/>
+        </p:nvPicPr>
+        <p:blipFill>
+          <a:blip r:embed="rId5"/>
+          <a:srcRect t="6696" r="15801" b="3456"/>
+          <a:stretch>
+            <a:fillRect/>
+          </a:stretch>
+        </p:blipFill>
+        <p:spPr>
+          <a:xfrm>
+            <a:off x="4406901" y="110797"/>
+            <a:ext cx="3476626" cy="1538824"/>
+          </a:xfrm>
+          <a:prstGeom prst="rect">
+            <a:avLst/>
+          </a:prstGeom>
+        </p:spPr>
+      </p:pic>
+      <p:pic>
+        <p:nvPicPr>
+          <p:cNvPr id="10" name="Picture 9">
+            <a:extLst>
+              <a:ext uri="{FF2B5EF4-FFF2-40B4-BE49-F238E27FC236}">
+                <a16:creationId xmlns:a16="http://schemas.microsoft.com/office/drawing/2014/main" id="{FB10E006-60F8-A3A6-C60D-53529E5793F7}"/>
+              </a:ext>
+            </a:extLst>
+          </p:cNvPr>
+          <p:cNvPicPr>
+            <a:picLocks noChangeAspect="1"/>
+          </p:cNvPicPr>
+          <p:nvPr/>
+        </p:nvPicPr>
+        <p:blipFill>
+          <a:blip r:embed="rId6"/>
+          <a:stretch>
+            <a:fillRect/>
+          </a:stretch>
+        </p:blipFill>
+        <p:spPr>
+          <a:xfrm>
+            <a:off x="7785100" y="3271719"/>
+            <a:ext cx="4406900" cy="3111500"/>
+          </a:xfrm>
+          <a:prstGeom prst="rect">
+            <a:avLst/>
+          </a:prstGeom>
+        </p:spPr>
+      </p:pic>
+      <p:pic>
+        <p:nvPicPr>
+          <p:cNvPr id="12" name="Picture 11">
+            <a:extLst>
+              <a:ext uri="{FF2B5EF4-FFF2-40B4-BE49-F238E27FC236}">
+                <a16:creationId xmlns:a16="http://schemas.microsoft.com/office/drawing/2014/main" id="{956BE1E2-CA8C-E0CC-D251-D013539796DC}"/>
+              </a:ext>
+            </a:extLst>
+          </p:cNvPr>
+          <p:cNvPicPr>
+            <a:picLocks noChangeAspect="1"/>
+          </p:cNvPicPr>
+          <p:nvPr/>
+        </p:nvPicPr>
+        <p:blipFill>
+          <a:blip r:embed="rId7"/>
+          <a:stretch>
+            <a:fillRect/>
+          </a:stretch>
+        </p:blipFill>
+        <p:spPr>
+          <a:xfrm>
+            <a:off x="7785100" y="93871"/>
+            <a:ext cx="4406900" cy="3111500"/>
+          </a:xfrm>
+          <a:prstGeom prst="rect">
+            <a:avLst/>
+          </a:prstGeom>
+        </p:spPr>
+      </p:pic>
+      <p:sp>
+        <p:nvSpPr>
+          <p:cNvPr id="21" name="Rak koppling 20">
+            <a:extLst>
+              <a:ext uri="{FF2B5EF4-FFF2-40B4-BE49-F238E27FC236}">
+                <a16:creationId xmlns:a16="http://schemas.microsoft.com/office/drawing/2014/main" id="{95D4B48C-F07A-4DE6-AE93-DAE37B8EADBE}"/>
+              </a:ext>
+            </a:extLst>
+          </p:cNvPr>
+          <p:cNvSpPr/>
+          <p:nvPr/>
+        </p:nvSpPr>
+        <p:spPr>
+          <a:xfrm rot="7897797">
+            <a:off x="3773784" y="5638680"/>
+            <a:ext cx="1463040" cy="0"/>
+          </a:xfrm>
+          <a:prstGeom prst="line">
+            <a:avLst/>
+          </a:prstGeom>
+          <a:solidFill>
+            <a:srgbClr val="FF0066">
+              <a:alpha val="5000"/>
+            </a:srgbClr>
+          </a:solidFill>
+          <a:ln w="12600">
+            <a:solidFill>
+              <a:srgbClr val="FF0066"/>
+            </a:solidFill>
+            <a:tailEnd type="arrow"/>
+          </a:ln>
+        </p:spPr>
+        <p:style>
+          <a:lnRef idx="2">
+            <a:schemeClr val="accent1"/>
+          </a:lnRef>
+          <a:fillRef idx="0">
+            <a:schemeClr val="accent1"/>
+          </a:fillRef>
+          <a:effectRef idx="1">
+            <a:schemeClr val="accent1"/>
+          </a:effectRef>
+          <a:fontRef idx="minor">
+            <a:schemeClr val="tx1"/>
+          </a:fontRef>
+        </p:style>
+        <p:txBody>
+          <a:bodyPr wrap="none" rtlCol="0" anchor="ctr" anchorCtr="1"/>
+          <a:lstStyle/>
+          <a:p>
+            <a:endParaRPr lang="ru-RU">
+              <a:solidFill>
+                <a:srgbClr val="FF0066"/>
+              </a:solidFill>
+            </a:endParaRPr>
+          </a:p>
+        </p:txBody>
+      </p:sp>
+      <p:sp>
+        <p:nvSpPr>
+          <p:cNvPr id="11" name="Rak koppling 10">
+            <a:extLst>
+              <a:ext uri="{FF2B5EF4-FFF2-40B4-BE49-F238E27FC236}">
+                <a16:creationId xmlns:a16="http://schemas.microsoft.com/office/drawing/2014/main" id="{88D7D897-61E1-4F02-8DBE-83E339C0DE8F}"/>
+              </a:ext>
+            </a:extLst>
+          </p:cNvPr>
+          <p:cNvSpPr/>
+          <p:nvPr/>
+        </p:nvSpPr>
+        <p:spPr>
+          <a:xfrm rot="2755194">
+            <a:off x="85442" y="5349060"/>
+            <a:ext cx="1280160" cy="0"/>
+          </a:xfrm>
+          <a:prstGeom prst="line">
+            <a:avLst/>
+          </a:prstGeom>
+          <a:solidFill>
+            <a:srgbClr val="FF0066">
+              <a:alpha val="5000"/>
+            </a:srgbClr>
+          </a:solidFill>
+          <a:ln w="12600">
+            <a:solidFill>
+              <a:srgbClr val="FF0066"/>
+            </a:solidFill>
+            <a:tailEnd type="arrow"/>
+          </a:ln>
+        </p:spPr>
+        <p:style>
+          <a:lnRef idx="2">
+            <a:schemeClr val="accent1"/>
+          </a:lnRef>
+          <a:fillRef idx="0">
+            <a:schemeClr val="accent1"/>
+          </a:fillRef>
+          <a:effectRef idx="1">
+            <a:schemeClr val="accent1"/>
+          </a:effectRef>
+          <a:fontRef idx="minor">
+            <a:schemeClr val="tx1"/>
+          </a:fontRef>
+        </p:style>
+        <p:txBody>
+          <a:bodyPr wrap="none" rtlCol="0" anchor="ctr" anchorCtr="1"/>
+          <a:lstStyle/>
+          <a:p>
+            <a:endParaRPr lang="ru-RU">
+              <a:solidFill>
+                <a:srgbClr val="FF0066"/>
+              </a:solidFill>
+            </a:endParaRPr>
+          </a:p>
+        </p:txBody>
+      </p:sp>
+    </p:spTree>
+    <p:extLst>
+      <p:ext uri="{BB962C8B-B14F-4D97-AF65-F5344CB8AC3E}">
+        <p14:creationId xmlns:p14="http://schemas.microsoft.com/office/powerpoint/2010/main" val="451879530"/>
+      </p:ext>
+    </p:extLst>
+  </p:cSld>
+  <p:clrMapOvr>
+    <a:masterClrMapping/>
+  </p:clrMapOvr>
+</p:sld>
+</file>
+
+<file path=ppt/slides/slide23.xml><?xml version="1.0" encoding="utf-8"?>
+<p:sld xmlns:a="http://schemas.openxmlformats.org/drawingml/2006/main" xmlns:r="http://schemas.openxmlformats.org/officeDocument/2006/relationships" xmlns:p="http://schemas.openxmlformats.org/presentationml/2006/main">
+  <p:cSld>
+    <p:spTree>
+      <p:nvGrpSpPr>
+        <p:cNvPr id="1" name="">
+          <a:extLst>
+            <a:ext uri="{FF2B5EF4-FFF2-40B4-BE49-F238E27FC236}">
+              <a16:creationId xmlns:a16="http://schemas.microsoft.com/office/drawing/2014/main" id="{D2F27AF9-C95C-5CC8-41D8-CC3E8D24664F}"/>
+            </a:ext>
+          </a:extLst>
+        </p:cNvPr>
+        <p:cNvGrpSpPr/>
+        <p:nvPr/>
+      </p:nvGrpSpPr>
+      <p:grpSpPr>
+        <a:xfrm>
+          <a:off x="0" y="0"/>
+          <a:ext cx="0" cy="0"/>
+          <a:chOff x="0" y="0"/>
+          <a:chExt cx="0" cy="0"/>
+        </a:xfrm>
+      </p:grpSpPr>
+      <p:sp>
+        <p:nvSpPr>
+          <p:cNvPr id="2" name="Title 1">
+            <a:extLst>
+              <a:ext uri="{FF2B5EF4-FFF2-40B4-BE49-F238E27FC236}">
+                <a16:creationId xmlns:a16="http://schemas.microsoft.com/office/drawing/2014/main" id="{B8600326-5432-B413-877F-4AD3CB5CBC54}"/>
+              </a:ext>
+            </a:extLst>
+          </p:cNvPr>
+          <p:cNvSpPr>
+            <a:spLocks noGrp="1"/>
+          </p:cNvSpPr>
+          <p:nvPr>
+            <p:ph type="title"/>
+          </p:nvPr>
+        </p:nvSpPr>
+        <p:spPr>
+          <a:xfrm>
+            <a:off x="266701" y="27523"/>
+            <a:ext cx="10515600" cy="1325563"/>
+          </a:xfrm>
+        </p:spPr>
+        <p:txBody>
+          <a:bodyPr/>
+          <a:lstStyle/>
+          <a:p>
+            <a:r>
+              <a:rPr lang="en-US" dirty="0"/>
+              <a:t>One-sample case – analysis (bidirectional)</a:t>
+            </a:r>
+          </a:p>
+        </p:txBody>
+      </p:sp>
+      <p:pic>
+        <p:nvPicPr>
+          <p:cNvPr id="4" name="Picture 3">
+            <a:extLst>
+              <a:ext uri="{FF2B5EF4-FFF2-40B4-BE49-F238E27FC236}">
+                <a16:creationId xmlns:a16="http://schemas.microsoft.com/office/drawing/2014/main" id="{B2BA73D8-1F3C-E12A-B21A-76E20687F499}"/>
+              </a:ext>
+            </a:extLst>
+          </p:cNvPr>
+          <p:cNvPicPr>
+            <a:picLocks noChangeAspect="1"/>
+          </p:cNvPicPr>
+          <p:nvPr/>
+        </p:nvPicPr>
+        <p:blipFill>
+          <a:blip r:embed="rId2"/>
+          <a:stretch>
+            <a:fillRect/>
+          </a:stretch>
+        </p:blipFill>
+        <p:spPr>
+          <a:xfrm>
+            <a:off x="5904714" y="1010186"/>
+            <a:ext cx="6020585" cy="4190464"/>
+          </a:xfrm>
+          <a:prstGeom prst="rect">
+            <a:avLst/>
+          </a:prstGeom>
+        </p:spPr>
+      </p:pic>
+      <p:pic>
+        <p:nvPicPr>
+          <p:cNvPr id="8" name="Picture 7">
+            <a:extLst>
+              <a:ext uri="{FF2B5EF4-FFF2-40B4-BE49-F238E27FC236}">
+                <a16:creationId xmlns:a16="http://schemas.microsoft.com/office/drawing/2014/main" id="{330B446D-1317-A744-CAAD-54BDE708EAAF}"/>
+              </a:ext>
+            </a:extLst>
+          </p:cNvPr>
+          <p:cNvPicPr>
+            <a:picLocks noChangeAspect="1"/>
+          </p:cNvPicPr>
+          <p:nvPr/>
+        </p:nvPicPr>
+        <p:blipFill>
+          <a:blip r:embed="rId3"/>
+          <a:stretch>
+            <a:fillRect/>
+          </a:stretch>
+        </p:blipFill>
+        <p:spPr>
+          <a:xfrm>
+            <a:off x="221537" y="1184543"/>
+            <a:ext cx="5519576" cy="3841750"/>
+          </a:xfrm>
+          <a:prstGeom prst="rect">
+            <a:avLst/>
+          </a:prstGeom>
+        </p:spPr>
+      </p:pic>
+      <p:graphicFrame>
+        <p:nvGraphicFramePr>
+          <p:cNvPr id="9" name="Table 8">
+            <a:extLst>
+              <a:ext uri="{FF2B5EF4-FFF2-40B4-BE49-F238E27FC236}">
+                <a16:creationId xmlns:a16="http://schemas.microsoft.com/office/drawing/2014/main" id="{8E9A36B2-CAB1-5E15-F919-ACE93171E3C3}"/>
+              </a:ext>
+            </a:extLst>
+          </p:cNvPr>
+          <p:cNvGraphicFramePr>
+            <a:graphicFrameLocks noGrp="1"/>
+          </p:cNvGraphicFramePr>
+          <p:nvPr>
+            <p:extLst>
+              <p:ext uri="{D42A27DB-BD31-4B8C-83A1-F6EECF244321}">
+                <p14:modId xmlns:p14="http://schemas.microsoft.com/office/powerpoint/2010/main" val="4107003987"/>
+              </p:ext>
+            </p:extLst>
+          </p:nvPr>
+        </p:nvGraphicFramePr>
+        <p:xfrm>
+          <a:off x="557213" y="5226734"/>
+          <a:ext cx="4471987" cy="893445"/>
+        </p:xfrm>
+        <a:graphic>
+          <a:graphicData uri="http://schemas.openxmlformats.org/drawingml/2006/table">
+            <a:tbl>
+              <a:tblPr>
+                <a:tableStyleId>{5C22544A-7EE6-4342-B048-85BDC9FD1C3A}</a:tableStyleId>
+              </a:tblPr>
+              <a:tblGrid>
+                <a:gridCol w="1038894">
+                  <a:extLst>
+                    <a:ext uri="{9D8B030D-6E8A-4147-A177-3AD203B41FA5}">
+                      <a16:colId xmlns:a16="http://schemas.microsoft.com/office/drawing/2014/main" val="1574204152"/>
+                    </a:ext>
+                  </a:extLst>
+                </a:gridCol>
+                <a:gridCol w="451769">
+                  <a:extLst>
+                    <a:ext uri="{9D8B030D-6E8A-4147-A177-3AD203B41FA5}">
+                      <a16:colId xmlns:a16="http://schemas.microsoft.com/office/drawing/2014/main" val="3974334677"/>
+                    </a:ext>
+                  </a:extLst>
+                </a:gridCol>
+                <a:gridCol w="745331">
+                  <a:extLst>
+                    <a:ext uri="{9D8B030D-6E8A-4147-A177-3AD203B41FA5}">
+                      <a16:colId xmlns:a16="http://schemas.microsoft.com/office/drawing/2014/main" val="2001218264"/>
+                    </a:ext>
+                  </a:extLst>
+                </a:gridCol>
+                <a:gridCol w="745331">
+                  <a:extLst>
+                    <a:ext uri="{9D8B030D-6E8A-4147-A177-3AD203B41FA5}">
+                      <a16:colId xmlns:a16="http://schemas.microsoft.com/office/drawing/2014/main" val="3362742547"/>
+                    </a:ext>
+                  </a:extLst>
+                </a:gridCol>
+                <a:gridCol w="745331">
+                  <a:extLst>
+                    <a:ext uri="{9D8B030D-6E8A-4147-A177-3AD203B41FA5}">
+                      <a16:colId xmlns:a16="http://schemas.microsoft.com/office/drawing/2014/main" val="1996554776"/>
+                    </a:ext>
+                  </a:extLst>
+                </a:gridCol>
+                <a:gridCol w="745331">
+                  <a:extLst>
+                    <a:ext uri="{9D8B030D-6E8A-4147-A177-3AD203B41FA5}">
+                      <a16:colId xmlns:a16="http://schemas.microsoft.com/office/drawing/2014/main" val="893165006"/>
+                    </a:ext>
+                  </a:extLst>
+                </a:gridCol>
+              </a:tblGrid>
+              <a:tr h="190500">
+                <a:tc>
+                  <a:txBody>
+                    <a:bodyPr/>
+                    <a:lstStyle/>
+                    <a:p>
+                      <a:pPr algn="ctr" fontAlgn="t">
+                        <a:buNone/>
+                      </a:pPr>
+                      <a:r>
+                        <a:rPr lang="en-US" sz="1100" u="none" strike="noStrike">
+                          <a:effectLst/>
+                        </a:rPr>
+                        <a:t>coords</a:t>
+                      </a:r>
+                      <a:endParaRPr lang="en-US" sz="1100" b="1" i="0" u="none" strike="noStrike">
+                        <a:solidFill>
+                          <a:srgbClr val="000000"/>
+                        </a:solidFill>
+                        <a:effectLst/>
+                        <a:latin typeface="Calibri" panose="020F0502020204030204" pitchFamily="34" charset="0"/>
+                      </a:endParaRPr>
+                    </a:p>
+                  </a:txBody>
+                  <a:tcPr marL="9525" marR="9525" marT="9525" marB="0"/>
+                </a:tc>
+                <a:tc>
+                  <a:txBody>
+                    <a:bodyPr/>
+                    <a:lstStyle/>
+                    <a:p>
+                      <a:pPr algn="ctr" fontAlgn="t">
+                        <a:buNone/>
+                      </a:pPr>
+                      <a:r>
+                        <a:rPr lang="en-US" sz="1100" u="none" strike="noStrike">
+                          <a:effectLst/>
+                        </a:rPr>
+                        <a:t>length</a:t>
+                      </a:r>
+                      <a:endParaRPr lang="en-US" sz="1100" b="1" i="0" u="none" strike="noStrike">
+                        <a:solidFill>
+                          <a:srgbClr val="000000"/>
+                        </a:solidFill>
+                        <a:effectLst/>
+                        <a:latin typeface="Calibri" panose="020F0502020204030204" pitchFamily="34" charset="0"/>
+                      </a:endParaRPr>
+                    </a:p>
+                  </a:txBody>
+                  <a:tcPr marL="9525" marR="9525" marT="9525" marB="0"/>
+                </a:tc>
+                <a:tc>
+                  <a:txBody>
+                    <a:bodyPr/>
+                    <a:lstStyle/>
+                    <a:p>
+                      <a:pPr algn="ctr" fontAlgn="t">
+                        <a:buNone/>
+                      </a:pPr>
+                      <a:r>
+                        <a:rPr lang="en-US" sz="1100" u="none" strike="noStrike">
+                          <a:effectLst/>
+                        </a:rPr>
+                        <a:t>score</a:t>
+                      </a:r>
+                      <a:endParaRPr lang="en-US" sz="1100" b="1" i="0" u="none" strike="noStrike">
+                        <a:solidFill>
+                          <a:srgbClr val="000000"/>
+                        </a:solidFill>
+                        <a:effectLst/>
+                        <a:latin typeface="Calibri" panose="020F0502020204030204" pitchFamily="34" charset="0"/>
+                      </a:endParaRPr>
+                    </a:p>
+                  </a:txBody>
+                  <a:tcPr marL="9525" marR="9525" marT="9525" marB="0"/>
+                </a:tc>
+                <a:tc>
+                  <a:txBody>
+                    <a:bodyPr/>
+                    <a:lstStyle/>
+                    <a:p>
+                      <a:pPr algn="ctr" fontAlgn="t">
+                        <a:buNone/>
+                      </a:pPr>
+                      <a:r>
+                        <a:rPr lang="en-US" sz="1100" u="none" strike="noStrike">
+                          <a:effectLst/>
+                        </a:rPr>
+                        <a:t>group1</a:t>
+                      </a:r>
+                      <a:endParaRPr lang="en-US" sz="1100" b="1" i="0" u="none" strike="noStrike">
+                        <a:solidFill>
+                          <a:srgbClr val="000000"/>
+                        </a:solidFill>
+                        <a:effectLst/>
+                        <a:latin typeface="Calibri" panose="020F0502020204030204" pitchFamily="34" charset="0"/>
+                      </a:endParaRPr>
+                    </a:p>
+                  </a:txBody>
+                  <a:tcPr marL="9525" marR="9525" marT="9525" marB="0"/>
+                </a:tc>
+                <a:tc>
+                  <a:txBody>
+                    <a:bodyPr/>
+                    <a:lstStyle/>
+                    <a:p>
+                      <a:pPr algn="ctr" fontAlgn="t">
+                        <a:buNone/>
+                      </a:pPr>
+                      <a:r>
+                        <a:rPr lang="en-US" sz="1100" u="none" strike="noStrike">
+                          <a:effectLst/>
+                        </a:rPr>
+                        <a:t>group2</a:t>
+                      </a:r>
+                      <a:endParaRPr lang="en-US" sz="1100" b="1" i="0" u="none" strike="noStrike">
+                        <a:solidFill>
+                          <a:srgbClr val="000000"/>
+                        </a:solidFill>
+                        <a:effectLst/>
+                        <a:latin typeface="Calibri" panose="020F0502020204030204" pitchFamily="34" charset="0"/>
+                      </a:endParaRPr>
+                    </a:p>
+                  </a:txBody>
+                  <a:tcPr marL="9525" marR="9525" marT="9525" marB="0"/>
+                </a:tc>
+                <a:tc>
+                  <a:txBody>
+                    <a:bodyPr/>
+                    <a:lstStyle/>
+                    <a:p>
+                      <a:pPr algn="ctr" fontAlgn="t">
+                        <a:buNone/>
+                      </a:pPr>
+                      <a:r>
+                        <a:rPr lang="en-US" sz="1100" u="none" strike="noStrike">
+                          <a:effectLst/>
+                        </a:rPr>
+                        <a:t>p_value</a:t>
+                      </a:r>
+                      <a:endParaRPr lang="en-US" sz="1100" b="1" i="0" u="none" strike="noStrike">
+                        <a:solidFill>
+                          <a:srgbClr val="000000"/>
+                        </a:solidFill>
+                        <a:effectLst/>
+                        <a:latin typeface="Calibri" panose="020F0502020204030204" pitchFamily="34" charset="0"/>
+                      </a:endParaRPr>
+                    </a:p>
+                  </a:txBody>
+                  <a:tcPr marL="9525" marR="9525" marT="9525" marB="0"/>
+                </a:tc>
+                <a:extLst>
+                  <a:ext uri="{0D108BD9-81ED-4DB2-BD59-A6C34878D82A}">
+                    <a16:rowId xmlns:a16="http://schemas.microsoft.com/office/drawing/2014/main" val="4184582648"/>
+                  </a:ext>
+                </a:extLst>
+              </a:tr>
+              <a:tr h="190500">
+                <a:tc>
+                  <a:txBody>
+                    <a:bodyPr/>
+                    <a:lstStyle/>
+                    <a:p>
+                      <a:pPr algn="l" fontAlgn="b">
+                        <a:buNone/>
+                      </a:pPr>
+                      <a:r>
+                        <a:rPr lang="en-US" sz="1100" u="none" strike="noStrike">
+                          <a:effectLst/>
+                        </a:rPr>
+                        <a:t>[(8, 0), (9, 1), (10, 2), (11, 3), (12, 4), (13, 5)]</a:t>
+                      </a:r>
+                      <a:endParaRPr lang="en-US" sz="1100" b="0" i="0" u="none" strike="noStrike">
+                        <a:solidFill>
+                          <a:srgbClr val="000000"/>
+                        </a:solidFill>
+                        <a:effectLst/>
+                        <a:latin typeface="Calibri" panose="020F0502020204030204" pitchFamily="34" charset="0"/>
+                      </a:endParaRPr>
+                    </a:p>
+                  </a:txBody>
+                  <a:tcPr marL="9525" marR="9525" marT="9525" marB="0" anchor="b"/>
+                </a:tc>
+                <a:tc>
+                  <a:txBody>
+                    <a:bodyPr/>
+                    <a:lstStyle/>
+                    <a:p>
+                      <a:pPr algn="r" fontAlgn="b">
+                        <a:buNone/>
+                      </a:pPr>
+                      <a:r>
+                        <a:rPr lang="en-US" sz="1100" u="none" strike="noStrike">
+                          <a:effectLst/>
+                        </a:rPr>
+                        <a:t>6</a:t>
+                      </a:r>
+                      <a:endParaRPr lang="en-US" sz="1100" b="0" i="0" u="none" strike="noStrike">
+                        <a:solidFill>
+                          <a:srgbClr val="000000"/>
+                        </a:solidFill>
+                        <a:effectLst/>
+                        <a:latin typeface="Calibri" panose="020F0502020204030204" pitchFamily="34" charset="0"/>
+                      </a:endParaRPr>
+                    </a:p>
+                  </a:txBody>
+                  <a:tcPr marL="9525" marR="9525" marT="9525" marB="0" anchor="b"/>
+                </a:tc>
+                <a:tc>
+                  <a:txBody>
+                    <a:bodyPr/>
+                    <a:lstStyle/>
+                    <a:p>
+                      <a:pPr algn="r" fontAlgn="b">
+                        <a:buNone/>
+                      </a:pPr>
+                      <a:r>
+                        <a:rPr lang="en-US" sz="1100" u="none" strike="noStrike">
+                          <a:effectLst/>
+                        </a:rPr>
+                        <a:t>12</a:t>
+                      </a:r>
+                      <a:endParaRPr lang="en-US" sz="1100" b="0" i="0" u="none" strike="noStrike">
+                        <a:solidFill>
+                          <a:srgbClr val="000000"/>
+                        </a:solidFill>
+                        <a:effectLst/>
+                        <a:latin typeface="Calibri" panose="020F0502020204030204" pitchFamily="34" charset="0"/>
+                      </a:endParaRPr>
+                    </a:p>
+                  </a:txBody>
+                  <a:tcPr marL="9525" marR="9525" marT="9525" marB="0" anchor="b"/>
+                </a:tc>
+                <a:tc>
+                  <a:txBody>
+                    <a:bodyPr/>
+                    <a:lstStyle/>
+                    <a:p>
+                      <a:pPr algn="l" fontAlgn="b">
+                        <a:buNone/>
+                      </a:pPr>
+                      <a:r>
+                        <a:rPr lang="en-US" sz="1100" u="none" strike="noStrike">
+                          <a:effectLst/>
+                        </a:rPr>
+                        <a:t>TGTACA</a:t>
+                      </a:r>
+                      <a:endParaRPr lang="en-US" sz="1100" b="0" i="0" u="none" strike="noStrike">
+                        <a:solidFill>
+                          <a:srgbClr val="000000"/>
+                        </a:solidFill>
+                        <a:effectLst/>
+                        <a:latin typeface="Calibri" panose="020F0502020204030204" pitchFamily="34" charset="0"/>
+                      </a:endParaRPr>
+                    </a:p>
+                  </a:txBody>
+                  <a:tcPr marL="9525" marR="9525" marT="9525" marB="0" anchor="b"/>
+                </a:tc>
+                <a:tc>
+                  <a:txBody>
+                    <a:bodyPr/>
+                    <a:lstStyle/>
+                    <a:p>
+                      <a:pPr algn="l" fontAlgn="b">
+                        <a:buNone/>
+                      </a:pPr>
+                      <a:r>
+                        <a:rPr lang="en-US" sz="1100" u="none" strike="noStrike">
+                          <a:effectLst/>
+                        </a:rPr>
+                        <a:t>TGTACA</a:t>
+                      </a:r>
+                      <a:endParaRPr lang="en-US" sz="1100" b="0" i="0" u="none" strike="noStrike">
+                        <a:solidFill>
+                          <a:srgbClr val="000000"/>
+                        </a:solidFill>
+                        <a:effectLst/>
+                        <a:latin typeface="Calibri" panose="020F0502020204030204" pitchFamily="34" charset="0"/>
+                      </a:endParaRPr>
+                    </a:p>
+                  </a:txBody>
+                  <a:tcPr marL="9525" marR="9525" marT="9525" marB="0" anchor="b"/>
+                </a:tc>
+                <a:tc>
+                  <a:txBody>
+                    <a:bodyPr/>
+                    <a:lstStyle/>
+                    <a:p>
+                      <a:pPr algn="r" fontAlgn="b">
+                        <a:buNone/>
+                      </a:pPr>
+                      <a:r>
+                        <a:rPr lang="en-US" sz="1100" u="none" strike="noStrike">
+                          <a:effectLst/>
+                        </a:rPr>
+                        <a:t>0.0036</a:t>
+                      </a:r>
+                      <a:endParaRPr lang="en-US" sz="1100" b="0" i="0" u="none" strike="noStrike">
+                        <a:solidFill>
+                          <a:srgbClr val="000000"/>
+                        </a:solidFill>
+                        <a:effectLst/>
+                        <a:latin typeface="Calibri" panose="020F0502020204030204" pitchFamily="34" charset="0"/>
+                      </a:endParaRPr>
+                    </a:p>
+                  </a:txBody>
+                  <a:tcPr marL="9525" marR="9525" marT="9525" marB="0" anchor="b"/>
+                </a:tc>
+                <a:extLst>
+                  <a:ext uri="{0D108BD9-81ED-4DB2-BD59-A6C34878D82A}">
+                    <a16:rowId xmlns:a16="http://schemas.microsoft.com/office/drawing/2014/main" val="1746780335"/>
+                  </a:ext>
+                </a:extLst>
+              </a:tr>
+              <a:tr h="190500">
+                <a:tc>
+                  <a:txBody>
+                    <a:bodyPr/>
+                    <a:lstStyle/>
+                    <a:p>
+                      <a:pPr algn="l" fontAlgn="b">
+                        <a:buNone/>
+                      </a:pPr>
+                      <a:r>
+                        <a:rPr lang="en-US" sz="1100" u="none" strike="noStrike">
+                          <a:effectLst/>
+                        </a:rPr>
+                        <a:t>[(6, 5), (7, 6)]</a:t>
+                      </a:r>
+                      <a:endParaRPr lang="en-US" sz="1100" b="0" i="0" u="none" strike="noStrike">
+                        <a:solidFill>
+                          <a:srgbClr val="000000"/>
+                        </a:solidFill>
+                        <a:effectLst/>
+                        <a:latin typeface="Calibri" panose="020F0502020204030204" pitchFamily="34" charset="0"/>
+                      </a:endParaRPr>
+                    </a:p>
+                  </a:txBody>
+                  <a:tcPr marL="9525" marR="9525" marT="9525" marB="0" anchor="b"/>
+                </a:tc>
+                <a:tc>
+                  <a:txBody>
+                    <a:bodyPr/>
+                    <a:lstStyle/>
+                    <a:p>
+                      <a:pPr algn="r" fontAlgn="b">
+                        <a:buNone/>
+                      </a:pPr>
+                      <a:r>
+                        <a:rPr lang="en-US" sz="1100" u="none" strike="noStrike">
+                          <a:effectLst/>
+                        </a:rPr>
+                        <a:t>2</a:t>
+                      </a:r>
+                      <a:endParaRPr lang="en-US" sz="1100" b="0" i="0" u="none" strike="noStrike">
+                        <a:solidFill>
+                          <a:srgbClr val="000000"/>
+                        </a:solidFill>
+                        <a:effectLst/>
+                        <a:latin typeface="Calibri" panose="020F0502020204030204" pitchFamily="34" charset="0"/>
+                      </a:endParaRPr>
+                    </a:p>
+                  </a:txBody>
+                  <a:tcPr marL="9525" marR="9525" marT="9525" marB="0" anchor="b"/>
+                </a:tc>
+                <a:tc>
+                  <a:txBody>
+                    <a:bodyPr/>
+                    <a:lstStyle/>
+                    <a:p>
+                      <a:pPr algn="r" fontAlgn="b">
+                        <a:buNone/>
+                      </a:pPr>
+                      <a:r>
+                        <a:rPr lang="en-US" sz="1100" u="none" strike="noStrike">
+                          <a:effectLst/>
+                        </a:rPr>
+                        <a:t>4</a:t>
+                      </a:r>
+                      <a:endParaRPr lang="en-US" sz="1100" b="0" i="0" u="none" strike="noStrike">
+                        <a:solidFill>
+                          <a:srgbClr val="000000"/>
+                        </a:solidFill>
+                        <a:effectLst/>
+                        <a:latin typeface="Calibri" panose="020F0502020204030204" pitchFamily="34" charset="0"/>
+                      </a:endParaRPr>
+                    </a:p>
+                  </a:txBody>
+                  <a:tcPr marL="9525" marR="9525" marT="9525" marB="0" anchor="b"/>
+                </a:tc>
+                <a:tc>
+                  <a:txBody>
+                    <a:bodyPr/>
+                    <a:lstStyle/>
+                    <a:p>
+                      <a:pPr algn="l" fontAlgn="b">
+                        <a:buNone/>
+                      </a:pPr>
+                      <a:r>
+                        <a:rPr lang="en-US" sz="1100" u="none" strike="noStrike">
+                          <a:effectLst/>
+                        </a:rPr>
+                        <a:t>AA</a:t>
+                      </a:r>
+                      <a:endParaRPr lang="en-US" sz="1100" b="0" i="0" u="none" strike="noStrike">
+                        <a:solidFill>
+                          <a:srgbClr val="000000"/>
+                        </a:solidFill>
+                        <a:effectLst/>
+                        <a:latin typeface="Calibri" panose="020F0502020204030204" pitchFamily="34" charset="0"/>
+                      </a:endParaRPr>
+                    </a:p>
+                  </a:txBody>
+                  <a:tcPr marL="9525" marR="9525" marT="9525" marB="0" anchor="b"/>
+                </a:tc>
+                <a:tc>
+                  <a:txBody>
+                    <a:bodyPr/>
+                    <a:lstStyle/>
+                    <a:p>
+                      <a:pPr algn="l" fontAlgn="b">
+                        <a:buNone/>
+                      </a:pPr>
+                      <a:r>
+                        <a:rPr lang="en-US" sz="1100" u="none" strike="noStrike">
+                          <a:effectLst/>
+                        </a:rPr>
+                        <a:t>AA</a:t>
+                      </a:r>
+                      <a:endParaRPr lang="en-US" sz="1100" b="0" i="0" u="none" strike="noStrike">
+                        <a:solidFill>
+                          <a:srgbClr val="000000"/>
+                        </a:solidFill>
+                        <a:effectLst/>
+                        <a:latin typeface="Calibri" panose="020F0502020204030204" pitchFamily="34" charset="0"/>
+                      </a:endParaRPr>
+                    </a:p>
+                  </a:txBody>
+                  <a:tcPr marL="9525" marR="9525" marT="9525" marB="0" anchor="b"/>
+                </a:tc>
+                <a:tc>
+                  <a:txBody>
+                    <a:bodyPr/>
+                    <a:lstStyle/>
+                    <a:p>
+                      <a:pPr algn="r" fontAlgn="b">
+                        <a:buNone/>
+                      </a:pPr>
+                      <a:r>
+                        <a:rPr lang="en-US" sz="1100" u="none" strike="noStrike" dirty="0">
+                          <a:effectLst/>
+                        </a:rPr>
+                        <a:t>1</a:t>
+                      </a:r>
+                      <a:endParaRPr lang="en-US" sz="1100" b="0" i="0" u="none" strike="noStrike" dirty="0">
+                        <a:solidFill>
+                          <a:srgbClr val="000000"/>
+                        </a:solidFill>
+                        <a:effectLst/>
+                        <a:latin typeface="Calibri" panose="020F0502020204030204" pitchFamily="34" charset="0"/>
+                      </a:endParaRPr>
+                    </a:p>
+                  </a:txBody>
+                  <a:tcPr marL="9525" marR="9525" marT="9525" marB="0" anchor="b"/>
+                </a:tc>
+                <a:extLst>
+                  <a:ext uri="{0D108BD9-81ED-4DB2-BD59-A6C34878D82A}">
+                    <a16:rowId xmlns:a16="http://schemas.microsoft.com/office/drawing/2014/main" val="2042222665"/>
+                  </a:ext>
+                </a:extLst>
+              </a:tr>
+            </a:tbl>
+          </a:graphicData>
+        </a:graphic>
+      </p:graphicFrame>
+      <p:graphicFrame>
+        <p:nvGraphicFramePr>
+          <p:cNvPr id="11" name="Table 10">
+            <a:extLst>
+              <a:ext uri="{FF2B5EF4-FFF2-40B4-BE49-F238E27FC236}">
+                <a16:creationId xmlns:a16="http://schemas.microsoft.com/office/drawing/2014/main" id="{A792DD8F-89C8-75B9-66F9-5736F04170FB}"/>
+              </a:ext>
+            </a:extLst>
+          </p:cNvPr>
+          <p:cNvGraphicFramePr>
+            <a:graphicFrameLocks noGrp="1"/>
+          </p:cNvGraphicFramePr>
+          <p:nvPr>
+            <p:extLst>
+              <p:ext uri="{D42A27DB-BD31-4B8C-83A1-F6EECF244321}">
+                <p14:modId xmlns:p14="http://schemas.microsoft.com/office/powerpoint/2010/main" val="357497975"/>
+              </p:ext>
+            </p:extLst>
+          </p:nvPr>
+        </p:nvGraphicFramePr>
+        <p:xfrm>
+          <a:off x="6272213" y="5026293"/>
+          <a:ext cx="5653086" cy="1709433"/>
+        </p:xfrm>
+        <a:graphic>
+          <a:graphicData uri="http://schemas.openxmlformats.org/drawingml/2006/table">
+            <a:tbl>
+              <a:tblPr>
+                <a:tableStyleId>{5C22544A-7EE6-4342-B048-85BDC9FD1C3A}</a:tableStyleId>
+              </a:tblPr>
+              <a:tblGrid>
+                <a:gridCol w="1140626">
+                  <a:extLst>
+                    <a:ext uri="{9D8B030D-6E8A-4147-A177-3AD203B41FA5}">
+                      <a16:colId xmlns:a16="http://schemas.microsoft.com/office/drawing/2014/main" val="1287844718"/>
+                    </a:ext>
+                  </a:extLst>
+                </a:gridCol>
+                <a:gridCol w="743736">
+                  <a:extLst>
+                    <a:ext uri="{9D8B030D-6E8A-4147-A177-3AD203B41FA5}">
+                      <a16:colId xmlns:a16="http://schemas.microsoft.com/office/drawing/2014/main" val="3359727422"/>
+                    </a:ext>
+                  </a:extLst>
+                </a:gridCol>
+                <a:gridCol w="942181">
+                  <a:extLst>
+                    <a:ext uri="{9D8B030D-6E8A-4147-A177-3AD203B41FA5}">
+                      <a16:colId xmlns:a16="http://schemas.microsoft.com/office/drawing/2014/main" val="2464027612"/>
+                    </a:ext>
+                  </a:extLst>
+                </a:gridCol>
+                <a:gridCol w="942181">
+                  <a:extLst>
+                    <a:ext uri="{9D8B030D-6E8A-4147-A177-3AD203B41FA5}">
+                      <a16:colId xmlns:a16="http://schemas.microsoft.com/office/drawing/2014/main" val="1840736092"/>
+                    </a:ext>
+                  </a:extLst>
+                </a:gridCol>
+                <a:gridCol w="942181">
+                  <a:extLst>
+                    <a:ext uri="{9D8B030D-6E8A-4147-A177-3AD203B41FA5}">
+                      <a16:colId xmlns:a16="http://schemas.microsoft.com/office/drawing/2014/main" val="2868734031"/>
+                    </a:ext>
+                  </a:extLst>
+                </a:gridCol>
+                <a:gridCol w="942181">
+                  <a:extLst>
+                    <a:ext uri="{9D8B030D-6E8A-4147-A177-3AD203B41FA5}">
+                      <a16:colId xmlns:a16="http://schemas.microsoft.com/office/drawing/2014/main" val="479424070"/>
+                    </a:ext>
+                  </a:extLst>
+                </a:gridCol>
+              </a:tblGrid>
+              <a:tr h="170852">
+                <a:tc>
+                  <a:txBody>
+                    <a:bodyPr/>
+                    <a:lstStyle/>
+                    <a:p>
+                      <a:pPr algn="ctr" fontAlgn="t">
+                        <a:buNone/>
+                      </a:pPr>
+                      <a:r>
+                        <a:rPr lang="en-US" sz="1100" u="none" strike="noStrike">
+                          <a:effectLst/>
+                        </a:rPr>
+                        <a:t>coords</a:t>
+                      </a:r>
+                      <a:endParaRPr lang="en-US" sz="1100" b="1" i="0" u="none" strike="noStrike">
+                        <a:solidFill>
+                          <a:srgbClr val="000000"/>
+                        </a:solidFill>
+                        <a:effectLst/>
+                        <a:latin typeface="Calibri" panose="020F0502020204030204" pitchFamily="34" charset="0"/>
+                      </a:endParaRPr>
+                    </a:p>
+                  </a:txBody>
+                  <a:tcPr marL="9525" marR="9525" marT="9525" marB="0"/>
+                </a:tc>
+                <a:tc>
+                  <a:txBody>
+                    <a:bodyPr/>
+                    <a:lstStyle/>
+                    <a:p>
+                      <a:pPr algn="ctr" fontAlgn="t">
+                        <a:buNone/>
+                      </a:pPr>
+                      <a:r>
+                        <a:rPr lang="en-US" sz="1100" u="none" strike="noStrike">
+                          <a:effectLst/>
+                        </a:rPr>
+                        <a:t>length</a:t>
+                      </a:r>
+                      <a:endParaRPr lang="en-US" sz="1100" b="1" i="0" u="none" strike="noStrike">
+                        <a:solidFill>
+                          <a:srgbClr val="000000"/>
+                        </a:solidFill>
+                        <a:effectLst/>
+                        <a:latin typeface="Calibri" panose="020F0502020204030204" pitchFamily="34" charset="0"/>
+                      </a:endParaRPr>
+                    </a:p>
+                  </a:txBody>
+                  <a:tcPr marL="9525" marR="9525" marT="9525" marB="0"/>
+                </a:tc>
+                <a:tc>
+                  <a:txBody>
+                    <a:bodyPr/>
+                    <a:lstStyle/>
+                    <a:p>
+                      <a:pPr algn="ctr" fontAlgn="t">
+                        <a:buNone/>
+                      </a:pPr>
+                      <a:r>
+                        <a:rPr lang="en-US" sz="1100" u="none" strike="noStrike">
+                          <a:effectLst/>
+                        </a:rPr>
+                        <a:t>score</a:t>
+                      </a:r>
+                      <a:endParaRPr lang="en-US" sz="1100" b="1" i="0" u="none" strike="noStrike">
+                        <a:solidFill>
+                          <a:srgbClr val="000000"/>
+                        </a:solidFill>
+                        <a:effectLst/>
+                        <a:latin typeface="Calibri" panose="020F0502020204030204" pitchFamily="34" charset="0"/>
+                      </a:endParaRPr>
+                    </a:p>
+                  </a:txBody>
+                  <a:tcPr marL="9525" marR="9525" marT="9525" marB="0"/>
+                </a:tc>
+                <a:tc>
+                  <a:txBody>
+                    <a:bodyPr/>
+                    <a:lstStyle/>
+                    <a:p>
+                      <a:pPr algn="ctr" fontAlgn="t">
+                        <a:buNone/>
+                      </a:pPr>
+                      <a:r>
+                        <a:rPr lang="en-US" sz="1100" u="none" strike="noStrike">
+                          <a:effectLst/>
+                        </a:rPr>
+                        <a:t>group1</a:t>
+                      </a:r>
+                      <a:endParaRPr lang="en-US" sz="1100" b="1" i="0" u="none" strike="noStrike">
+                        <a:solidFill>
+                          <a:srgbClr val="000000"/>
+                        </a:solidFill>
+                        <a:effectLst/>
+                        <a:latin typeface="Calibri" panose="020F0502020204030204" pitchFamily="34" charset="0"/>
+                      </a:endParaRPr>
+                    </a:p>
+                  </a:txBody>
+                  <a:tcPr marL="9525" marR="9525" marT="9525" marB="0"/>
+                </a:tc>
+                <a:tc>
+                  <a:txBody>
+                    <a:bodyPr/>
+                    <a:lstStyle/>
+                    <a:p>
+                      <a:pPr algn="ctr" fontAlgn="t">
+                        <a:buNone/>
+                      </a:pPr>
+                      <a:r>
+                        <a:rPr lang="en-US" sz="1100" u="none" strike="noStrike">
+                          <a:effectLst/>
+                        </a:rPr>
+                        <a:t>group2</a:t>
+                      </a:r>
+                      <a:endParaRPr lang="en-US" sz="1100" b="1" i="0" u="none" strike="noStrike">
+                        <a:solidFill>
+                          <a:srgbClr val="000000"/>
+                        </a:solidFill>
+                        <a:effectLst/>
+                        <a:latin typeface="Calibri" panose="020F0502020204030204" pitchFamily="34" charset="0"/>
+                      </a:endParaRPr>
+                    </a:p>
+                  </a:txBody>
+                  <a:tcPr marL="9525" marR="9525" marT="9525" marB="0"/>
+                </a:tc>
+                <a:tc>
+                  <a:txBody>
+                    <a:bodyPr/>
+                    <a:lstStyle/>
+                    <a:p>
+                      <a:pPr algn="ctr" fontAlgn="t">
+                        <a:buNone/>
+                      </a:pPr>
+                      <a:r>
+                        <a:rPr lang="en-US" sz="1100" u="none" strike="noStrike">
+                          <a:effectLst/>
+                        </a:rPr>
+                        <a:t>p_value</a:t>
+                      </a:r>
+                      <a:endParaRPr lang="en-US" sz="1100" b="1" i="0" u="none" strike="noStrike">
+                        <a:solidFill>
+                          <a:srgbClr val="000000"/>
+                        </a:solidFill>
+                        <a:effectLst/>
+                        <a:latin typeface="Calibri" panose="020F0502020204030204" pitchFamily="34" charset="0"/>
+                      </a:endParaRPr>
+                    </a:p>
+                  </a:txBody>
+                  <a:tcPr marL="9525" marR="9525" marT="9525" marB="0"/>
+                </a:tc>
+                <a:extLst>
+                  <a:ext uri="{0D108BD9-81ED-4DB2-BD59-A6C34878D82A}">
+                    <a16:rowId xmlns:a16="http://schemas.microsoft.com/office/drawing/2014/main" val="4047524456"/>
+                  </a:ext>
+                </a:extLst>
+              </a:tr>
+              <a:tr h="760293">
+                <a:tc>
+                  <a:txBody>
+                    <a:bodyPr/>
+                    <a:lstStyle/>
+                    <a:p>
+                      <a:pPr algn="l" fontAlgn="b">
+                        <a:buNone/>
+                      </a:pPr>
+                      <a:r>
+                        <a:rPr lang="en-US" sz="1100" u="none" strike="noStrike">
+                          <a:effectLst/>
+                        </a:rPr>
+                        <a:t>[(8, 5), (9, 4), (10, 3), (11, 2), (12, 1), (13, 0)]</a:t>
+                      </a:r>
+                      <a:endParaRPr lang="en-US" sz="1100" b="0" i="0" u="none" strike="noStrike">
+                        <a:solidFill>
+                          <a:srgbClr val="000000"/>
+                        </a:solidFill>
+                        <a:effectLst/>
+                        <a:latin typeface="Calibri" panose="020F0502020204030204" pitchFamily="34" charset="0"/>
+                      </a:endParaRPr>
+                    </a:p>
+                  </a:txBody>
+                  <a:tcPr marL="9525" marR="9525" marT="9525" marB="0" anchor="b"/>
+                </a:tc>
+                <a:tc>
+                  <a:txBody>
+                    <a:bodyPr/>
+                    <a:lstStyle/>
+                    <a:p>
+                      <a:pPr algn="r" fontAlgn="b">
+                        <a:buNone/>
+                      </a:pPr>
+                      <a:r>
+                        <a:rPr lang="en-US" sz="1100" u="none" strike="noStrike">
+                          <a:effectLst/>
+                        </a:rPr>
+                        <a:t>6</a:t>
+                      </a:r>
+                      <a:endParaRPr lang="en-US" sz="1100" b="0" i="0" u="none" strike="noStrike">
+                        <a:solidFill>
+                          <a:srgbClr val="000000"/>
+                        </a:solidFill>
+                        <a:effectLst/>
+                        <a:latin typeface="Calibri" panose="020F0502020204030204" pitchFamily="34" charset="0"/>
+                      </a:endParaRPr>
+                    </a:p>
+                  </a:txBody>
+                  <a:tcPr marL="9525" marR="9525" marT="9525" marB="0" anchor="b"/>
+                </a:tc>
+                <a:tc>
+                  <a:txBody>
+                    <a:bodyPr/>
+                    <a:lstStyle/>
+                    <a:p>
+                      <a:pPr algn="r" fontAlgn="b">
+                        <a:buNone/>
+                      </a:pPr>
+                      <a:r>
+                        <a:rPr lang="en-US" sz="1100" u="none" strike="noStrike">
+                          <a:effectLst/>
+                        </a:rPr>
+                        <a:t>12</a:t>
+                      </a:r>
+                      <a:endParaRPr lang="en-US" sz="1100" b="0" i="0" u="none" strike="noStrike">
+                        <a:solidFill>
+                          <a:srgbClr val="000000"/>
+                        </a:solidFill>
+                        <a:effectLst/>
+                        <a:latin typeface="Calibri" panose="020F0502020204030204" pitchFamily="34" charset="0"/>
+                      </a:endParaRPr>
+                    </a:p>
+                  </a:txBody>
+                  <a:tcPr marL="9525" marR="9525" marT="9525" marB="0" anchor="b"/>
+                </a:tc>
+                <a:tc>
+                  <a:txBody>
+                    <a:bodyPr/>
+                    <a:lstStyle/>
+                    <a:p>
+                      <a:pPr algn="l" fontAlgn="b">
+                        <a:buNone/>
+                      </a:pPr>
+                      <a:r>
+                        <a:rPr lang="en-US" sz="1100" u="none" strike="noStrike">
+                          <a:effectLst/>
+                        </a:rPr>
+                        <a:t>TGTACA</a:t>
+                      </a:r>
+                      <a:endParaRPr lang="en-US" sz="1100" b="0" i="0" u="none" strike="noStrike">
+                        <a:solidFill>
+                          <a:srgbClr val="000000"/>
+                        </a:solidFill>
+                        <a:effectLst/>
+                        <a:latin typeface="Calibri" panose="020F0502020204030204" pitchFamily="34" charset="0"/>
+                      </a:endParaRPr>
+                    </a:p>
+                  </a:txBody>
+                  <a:tcPr marL="9525" marR="9525" marT="9525" marB="0" anchor="b"/>
+                </a:tc>
+                <a:tc>
+                  <a:txBody>
+                    <a:bodyPr/>
+                    <a:lstStyle/>
+                    <a:p>
+                      <a:pPr algn="l" fontAlgn="b">
+                        <a:buNone/>
+                      </a:pPr>
+                      <a:r>
+                        <a:rPr lang="en-US" sz="1100" u="none" strike="noStrike">
+                          <a:effectLst/>
+                        </a:rPr>
+                        <a:t>ACATGT</a:t>
+                      </a:r>
+                      <a:endParaRPr lang="en-US" sz="1100" b="0" i="0" u="none" strike="noStrike">
+                        <a:solidFill>
+                          <a:srgbClr val="000000"/>
+                        </a:solidFill>
+                        <a:effectLst/>
+                        <a:latin typeface="Calibri" panose="020F0502020204030204" pitchFamily="34" charset="0"/>
+                      </a:endParaRPr>
+                    </a:p>
+                  </a:txBody>
+                  <a:tcPr marL="9525" marR="9525" marT="9525" marB="0" anchor="b"/>
+                </a:tc>
+                <a:tc>
+                  <a:txBody>
+                    <a:bodyPr/>
+                    <a:lstStyle/>
+                    <a:p>
+                      <a:pPr algn="r" fontAlgn="b">
+                        <a:buNone/>
+                      </a:pPr>
+                      <a:r>
+                        <a:rPr lang="en-US" sz="1100" u="none" strike="noStrike">
+                          <a:effectLst/>
+                        </a:rPr>
+                        <a:t>0.0046</a:t>
+                      </a:r>
+                      <a:endParaRPr lang="en-US" sz="1100" b="0" i="0" u="none" strike="noStrike">
+                        <a:solidFill>
+                          <a:srgbClr val="000000"/>
+                        </a:solidFill>
+                        <a:effectLst/>
+                        <a:latin typeface="Calibri" panose="020F0502020204030204" pitchFamily="34" charset="0"/>
+                      </a:endParaRPr>
+                    </a:p>
+                  </a:txBody>
+                  <a:tcPr marL="9525" marR="9525" marT="9525" marB="0" anchor="b"/>
+                </a:tc>
+                <a:extLst>
+                  <a:ext uri="{0D108BD9-81ED-4DB2-BD59-A6C34878D82A}">
+                    <a16:rowId xmlns:a16="http://schemas.microsoft.com/office/drawing/2014/main" val="1081731856"/>
+                  </a:ext>
+                </a:extLst>
+              </a:tr>
+              <a:tr h="312382">
+                <a:tc>
+                  <a:txBody>
+                    <a:bodyPr/>
+                    <a:lstStyle/>
+                    <a:p>
+                      <a:pPr algn="l" fontAlgn="b">
+                        <a:buNone/>
+                      </a:pPr>
+                      <a:r>
+                        <a:rPr lang="en-US" sz="1100" u="none" strike="noStrike">
+                          <a:effectLst/>
+                        </a:rPr>
+                        <a:t>[(3, 2), (4, 1), (5, 0)]</a:t>
+                      </a:r>
+                      <a:endParaRPr lang="en-US" sz="1100" b="0" i="0" u="none" strike="noStrike">
+                        <a:solidFill>
+                          <a:srgbClr val="000000"/>
+                        </a:solidFill>
+                        <a:effectLst/>
+                        <a:latin typeface="Calibri" panose="020F0502020204030204" pitchFamily="34" charset="0"/>
+                      </a:endParaRPr>
+                    </a:p>
+                  </a:txBody>
+                  <a:tcPr marL="9525" marR="9525" marT="9525" marB="0" anchor="b"/>
+                </a:tc>
+                <a:tc>
+                  <a:txBody>
+                    <a:bodyPr/>
+                    <a:lstStyle/>
+                    <a:p>
+                      <a:pPr algn="r" fontAlgn="b">
+                        <a:buNone/>
+                      </a:pPr>
+                      <a:r>
+                        <a:rPr lang="en-US" sz="1100" u="none" strike="noStrike">
+                          <a:effectLst/>
+                        </a:rPr>
+                        <a:t>3</a:t>
+                      </a:r>
+                      <a:endParaRPr lang="en-US" sz="1100" b="0" i="0" u="none" strike="noStrike">
+                        <a:solidFill>
+                          <a:srgbClr val="000000"/>
+                        </a:solidFill>
+                        <a:effectLst/>
+                        <a:latin typeface="Calibri" panose="020F0502020204030204" pitchFamily="34" charset="0"/>
+                      </a:endParaRPr>
+                    </a:p>
+                  </a:txBody>
+                  <a:tcPr marL="9525" marR="9525" marT="9525" marB="0" anchor="b"/>
+                </a:tc>
+                <a:tc>
+                  <a:txBody>
+                    <a:bodyPr/>
+                    <a:lstStyle/>
+                    <a:p>
+                      <a:pPr algn="r" fontAlgn="b">
+                        <a:buNone/>
+                      </a:pPr>
+                      <a:r>
+                        <a:rPr lang="en-US" sz="1100" u="none" strike="noStrike">
+                          <a:effectLst/>
+                        </a:rPr>
+                        <a:t>6</a:t>
+                      </a:r>
+                      <a:endParaRPr lang="en-US" sz="1100" b="0" i="0" u="none" strike="noStrike">
+                        <a:solidFill>
+                          <a:srgbClr val="000000"/>
+                        </a:solidFill>
+                        <a:effectLst/>
+                        <a:latin typeface="Calibri" panose="020F0502020204030204" pitchFamily="34" charset="0"/>
+                      </a:endParaRPr>
+                    </a:p>
+                  </a:txBody>
+                  <a:tcPr marL="9525" marR="9525" marT="9525" marB="0" anchor="b"/>
+                </a:tc>
+                <a:tc>
+                  <a:txBody>
+                    <a:bodyPr/>
+                    <a:lstStyle/>
+                    <a:p>
+                      <a:pPr algn="l" fontAlgn="b">
+                        <a:buNone/>
+                      </a:pPr>
+                      <a:r>
+                        <a:rPr lang="en-US" sz="1100" u="none" strike="noStrike">
+                          <a:effectLst/>
+                        </a:rPr>
+                        <a:t>ACA</a:t>
+                      </a:r>
+                      <a:endParaRPr lang="en-US" sz="1100" b="0" i="0" u="none" strike="noStrike">
+                        <a:solidFill>
+                          <a:srgbClr val="000000"/>
+                        </a:solidFill>
+                        <a:effectLst/>
+                        <a:latin typeface="Calibri" panose="020F0502020204030204" pitchFamily="34" charset="0"/>
+                      </a:endParaRPr>
+                    </a:p>
+                  </a:txBody>
+                  <a:tcPr marL="9525" marR="9525" marT="9525" marB="0" anchor="b"/>
+                </a:tc>
+                <a:tc>
+                  <a:txBody>
+                    <a:bodyPr/>
+                    <a:lstStyle/>
+                    <a:p>
+                      <a:pPr algn="l" fontAlgn="b">
+                        <a:buNone/>
+                      </a:pPr>
+                      <a:r>
+                        <a:rPr lang="en-US" sz="1100" u="none" strike="noStrike">
+                          <a:effectLst/>
+                        </a:rPr>
+                        <a:t>TGT</a:t>
+                      </a:r>
+                      <a:endParaRPr lang="en-US" sz="1100" b="0" i="0" u="none" strike="noStrike">
+                        <a:solidFill>
+                          <a:srgbClr val="000000"/>
+                        </a:solidFill>
+                        <a:effectLst/>
+                        <a:latin typeface="Calibri" panose="020F0502020204030204" pitchFamily="34" charset="0"/>
+                      </a:endParaRPr>
+                    </a:p>
+                  </a:txBody>
+                  <a:tcPr marL="9525" marR="9525" marT="9525" marB="0" anchor="b"/>
+                </a:tc>
+                <a:tc>
+                  <a:txBody>
+                    <a:bodyPr/>
+                    <a:lstStyle/>
+                    <a:p>
+                      <a:pPr algn="r" fontAlgn="b">
+                        <a:buNone/>
+                      </a:pPr>
+                      <a:r>
+                        <a:rPr lang="en-US" sz="1100" u="none" strike="noStrike">
+                          <a:effectLst/>
+                        </a:rPr>
+                        <a:t>0.6868</a:t>
+                      </a:r>
+                      <a:endParaRPr lang="en-US" sz="1100" b="0" i="0" u="none" strike="noStrike">
+                        <a:solidFill>
+                          <a:srgbClr val="000000"/>
+                        </a:solidFill>
+                        <a:effectLst/>
+                        <a:latin typeface="Calibri" panose="020F0502020204030204" pitchFamily="34" charset="0"/>
+                      </a:endParaRPr>
+                    </a:p>
+                  </a:txBody>
+                  <a:tcPr marL="9525" marR="9525" marT="9525" marB="0" anchor="b"/>
+                </a:tc>
+                <a:extLst>
+                  <a:ext uri="{0D108BD9-81ED-4DB2-BD59-A6C34878D82A}">
+                    <a16:rowId xmlns:a16="http://schemas.microsoft.com/office/drawing/2014/main" val="1881929189"/>
+                  </a:ext>
+                </a:extLst>
+              </a:tr>
+              <a:tr h="459593">
+                <a:tc>
+                  <a:txBody>
+                    <a:bodyPr/>
+                    <a:lstStyle/>
+                    <a:p>
+                      <a:pPr algn="l" fontAlgn="b">
+                        <a:buNone/>
+                      </a:pPr>
+                      <a:r>
+                        <a:rPr lang="en-US" sz="1100" u="none" strike="noStrike">
+                          <a:effectLst/>
+                        </a:rPr>
+                        <a:t>[(11, 10), (12, 9), (13, 8)]</a:t>
+                      </a:r>
+                      <a:endParaRPr lang="en-US" sz="1100" b="0" i="0" u="none" strike="noStrike">
+                        <a:solidFill>
+                          <a:srgbClr val="000000"/>
+                        </a:solidFill>
+                        <a:effectLst/>
+                        <a:latin typeface="Calibri" panose="020F0502020204030204" pitchFamily="34" charset="0"/>
+                      </a:endParaRPr>
+                    </a:p>
+                  </a:txBody>
+                  <a:tcPr marL="9525" marR="9525" marT="9525" marB="0" anchor="b"/>
+                </a:tc>
+                <a:tc>
+                  <a:txBody>
+                    <a:bodyPr/>
+                    <a:lstStyle/>
+                    <a:p>
+                      <a:pPr algn="r" fontAlgn="b">
+                        <a:buNone/>
+                      </a:pPr>
+                      <a:r>
+                        <a:rPr lang="en-US" sz="1100" u="none" strike="noStrike">
+                          <a:effectLst/>
+                        </a:rPr>
+                        <a:t>3</a:t>
+                      </a:r>
+                      <a:endParaRPr lang="en-US" sz="1100" b="0" i="0" u="none" strike="noStrike">
+                        <a:solidFill>
+                          <a:srgbClr val="000000"/>
+                        </a:solidFill>
+                        <a:effectLst/>
+                        <a:latin typeface="Calibri" panose="020F0502020204030204" pitchFamily="34" charset="0"/>
+                      </a:endParaRPr>
+                    </a:p>
+                  </a:txBody>
+                  <a:tcPr marL="9525" marR="9525" marT="9525" marB="0" anchor="b"/>
+                </a:tc>
+                <a:tc>
+                  <a:txBody>
+                    <a:bodyPr/>
+                    <a:lstStyle/>
+                    <a:p>
+                      <a:pPr algn="r" fontAlgn="b">
+                        <a:buNone/>
+                      </a:pPr>
+                      <a:r>
+                        <a:rPr lang="en-US" sz="1100" u="none" strike="noStrike">
+                          <a:effectLst/>
+                        </a:rPr>
+                        <a:t>6</a:t>
+                      </a:r>
+                      <a:endParaRPr lang="en-US" sz="1100" b="0" i="0" u="none" strike="noStrike">
+                        <a:solidFill>
+                          <a:srgbClr val="000000"/>
+                        </a:solidFill>
+                        <a:effectLst/>
+                        <a:latin typeface="Calibri" panose="020F0502020204030204" pitchFamily="34" charset="0"/>
+                      </a:endParaRPr>
+                    </a:p>
+                  </a:txBody>
+                  <a:tcPr marL="9525" marR="9525" marT="9525" marB="0" anchor="b"/>
+                </a:tc>
+                <a:tc>
+                  <a:txBody>
+                    <a:bodyPr/>
+                    <a:lstStyle/>
+                    <a:p>
+                      <a:pPr algn="l" fontAlgn="b">
+                        <a:buNone/>
+                      </a:pPr>
+                      <a:r>
+                        <a:rPr lang="en-US" sz="1100" u="none" strike="noStrike">
+                          <a:effectLst/>
+                        </a:rPr>
+                        <a:t>ACA</a:t>
+                      </a:r>
+                      <a:endParaRPr lang="en-US" sz="1100" b="0" i="0" u="none" strike="noStrike">
+                        <a:solidFill>
+                          <a:srgbClr val="000000"/>
+                        </a:solidFill>
+                        <a:effectLst/>
+                        <a:latin typeface="Calibri" panose="020F0502020204030204" pitchFamily="34" charset="0"/>
+                      </a:endParaRPr>
+                    </a:p>
+                  </a:txBody>
+                  <a:tcPr marL="9525" marR="9525" marT="9525" marB="0" anchor="b"/>
+                </a:tc>
+                <a:tc>
+                  <a:txBody>
+                    <a:bodyPr/>
+                    <a:lstStyle/>
+                    <a:p>
+                      <a:pPr algn="l" fontAlgn="b">
+                        <a:buNone/>
+                      </a:pPr>
+                      <a:r>
+                        <a:rPr lang="en-US" sz="1100" u="none" strike="noStrike">
+                          <a:effectLst/>
+                        </a:rPr>
+                        <a:t>TGT</a:t>
+                      </a:r>
+                      <a:endParaRPr lang="en-US" sz="1100" b="0" i="0" u="none" strike="noStrike">
+                        <a:solidFill>
+                          <a:srgbClr val="000000"/>
+                        </a:solidFill>
+                        <a:effectLst/>
+                        <a:latin typeface="Calibri" panose="020F0502020204030204" pitchFamily="34" charset="0"/>
+                      </a:endParaRPr>
+                    </a:p>
+                  </a:txBody>
+                  <a:tcPr marL="9525" marR="9525" marT="9525" marB="0" anchor="b"/>
+                </a:tc>
+                <a:tc>
+                  <a:txBody>
+                    <a:bodyPr/>
+                    <a:lstStyle/>
+                    <a:p>
+                      <a:pPr algn="r" fontAlgn="b">
+                        <a:buNone/>
+                      </a:pPr>
+                      <a:r>
+                        <a:rPr lang="en-US" sz="1100" u="none" strike="noStrike" dirty="0">
+                          <a:effectLst/>
+                        </a:rPr>
+                        <a:t>0.6868</a:t>
+                      </a:r>
+                      <a:endParaRPr lang="en-US" sz="1100" b="0" i="0" u="none" strike="noStrike" dirty="0">
+                        <a:solidFill>
+                          <a:srgbClr val="000000"/>
+                        </a:solidFill>
+                        <a:effectLst/>
+                        <a:latin typeface="Calibri" panose="020F0502020204030204" pitchFamily="34" charset="0"/>
+                      </a:endParaRPr>
+                    </a:p>
+                  </a:txBody>
+                  <a:tcPr marL="9525" marR="9525" marT="9525" marB="0" anchor="b"/>
+                </a:tc>
+                <a:extLst>
+                  <a:ext uri="{0D108BD9-81ED-4DB2-BD59-A6C34878D82A}">
+                    <a16:rowId xmlns:a16="http://schemas.microsoft.com/office/drawing/2014/main" val="542206097"/>
+                  </a:ext>
+                </a:extLst>
+              </a:tr>
+            </a:tbl>
+          </a:graphicData>
+        </a:graphic>
+      </p:graphicFrame>
+    </p:spTree>
+    <p:extLst>
+      <p:ext uri="{BB962C8B-B14F-4D97-AF65-F5344CB8AC3E}">
+        <p14:creationId xmlns:p14="http://schemas.microsoft.com/office/powerpoint/2010/main" val="1244999649"/>
       </p:ext>
     </p:extLst>
   </p:cSld>
@@ -11296,7 +13224,7 @@
           <p:nvPr/>
         </p:nvPicPr>
         <p:blipFill>
-          <a:blip r:embed="rId2"/>
+          <a:blip/>
           <a:stretch>
             <a:fillRect/>
           </a:stretch>
@@ -11326,7 +13254,7 @@
           <p:nvPr/>
         </p:nvPicPr>
         <p:blipFill>
-          <a:blip r:embed="rId3"/>
+          <a:blip/>
           <a:stretch>
             <a:fillRect/>
           </a:stretch>
@@ -11541,7 +13469,7 @@
           <p:nvPr/>
         </p:nvPicPr>
         <p:blipFill>
-          <a:blip r:embed="rId2"/>
+          <a:blip/>
           <a:stretch>
             <a:fillRect/>
           </a:stretch>
@@ -15217,7 +17145,7 @@
           <p:nvPr/>
         </p:nvPicPr>
         <p:blipFill>
-          <a:blip r:embed="rId2"/>
+          <a:blip/>
           <a:stretch>
             <a:fillRect/>
           </a:stretch>
@@ -15247,7 +17175,7 @@
           <p:nvPr/>
         </p:nvPicPr>
         <p:blipFill>
-          <a:blip r:embed="rId3"/>
+          <a:blip/>
           <a:srcRect l="8457" t="13806" r="4937"/>
           <a:stretch>
             <a:fillRect/>
@@ -15543,7 +17471,7 @@
           </p:nvPr>
         </p:nvPicPr>
         <p:blipFill>
-          <a:blip r:embed="rId2"/>
+          <a:blip/>
           <a:stretch>
             <a:fillRect/>
           </a:stretch>
@@ -15570,7 +17498,7 @@
           <p:nvPr/>
         </p:nvPicPr>
         <p:blipFill>
-          <a:blip r:embed="rId3"/>
+          <a:blip/>
           <a:stretch>
             <a:fillRect/>
           </a:stretch>
@@ -15600,7 +17528,7 @@
           <p:nvPr/>
         </p:nvPicPr>
         <p:blipFill>
-          <a:blip r:embed="rId4"/>
+          <a:blip/>
           <a:stretch>
             <a:fillRect/>
           </a:stretch>
@@ -15701,7 +17629,7 @@
           </p:nvPr>
         </p:nvPicPr>
         <p:blipFill>
-          <a:blip r:embed="rId2"/>
+          <a:blip/>
           <a:stretch>
             <a:fillRect/>
           </a:stretch>
@@ -19174,7 +21102,7 @@
           <p:nvPr/>
         </p:nvPicPr>
         <p:blipFill>
-          <a:blip r:embed="rId3"/>
+          <a:blip/>
           <a:stretch>
             <a:fillRect/>
           </a:stretch>
@@ -19286,7 +21214,7 @@
           </p:nvPr>
         </p:nvPicPr>
         <p:blipFill>
-          <a:blip r:embed="rId3"/>
+          <a:blip/>
           <a:stretch>
             <a:fillRect/>
           </a:stretch>
@@ -19313,7 +21241,7 @@
           <p:nvPr/>
         </p:nvPicPr>
         <p:blipFill>
-          <a:blip r:embed="rId4"/>
+          <a:blip/>
           <a:stretch>
             <a:fillRect/>
           </a:stretch>
@@ -19343,7 +21271,7 @@
           <p:nvPr/>
         </p:nvPicPr>
         <p:blipFill>
-          <a:blip r:embed="rId5"/>
+          <a:blip/>
           <a:stretch>
             <a:fillRect/>
           </a:stretch>

</xml_diff>